<commit_message>
Order horizontal bar charts highest first
</commit_message>
<xml_diff>
--- a/references/plain-fallback-100-layouts.pptx
+++ b/references/plain-fallback-100-layouts.pptx
@@ -442,7 +442,7 @@
       <c:catAx>
         <c:axId val="-2068027336"/>
         <c:scaling>
-          <c:orientation val="minMax"/>
+          <c:orientation val="maxMin"/>
         </c:scaling>
         <c:delete val="0"/>
         <c:axPos val="l"/>
@@ -1989,7 +1989,7 @@
       <c:catAx>
         <c:axId val="-2068027336"/>
         <c:scaling>
-          <c:orientation val="minMax"/>
+          <c:orientation val="maxMin"/>
         </c:scaling>
         <c:delete val="0"/>
         <c:axPos val="l"/>
@@ -3361,7 +3361,7 @@
       <c:catAx>
         <c:axId val="-2068027336"/>
         <c:scaling>
-          <c:orientation val="minMax"/>
+          <c:orientation val="maxMin"/>
         </c:scaling>
         <c:delete val="0"/>
         <c:axPos val="l"/>
@@ -3564,7 +3564,7 @@
       <c:catAx>
         <c:axId val="-2068027336"/>
         <c:scaling>
-          <c:orientation val="minMax"/>
+          <c:orientation val="maxMin"/>
         </c:scaling>
         <c:delete val="0"/>
         <c:axPos val="l"/>
@@ -3838,7 +3838,7 @@
       <c:catAx>
         <c:axId val="-2068027336"/>
         <c:scaling>
-          <c:orientation val="minMax"/>
+          <c:orientation val="maxMin"/>
         </c:scaling>
         <c:delete val="0"/>
         <c:axPos val="l"/>
@@ -4112,7 +4112,7 @@
       <c:catAx>
         <c:axId val="-2068027336"/>
         <c:scaling>
-          <c:orientation val="minMax"/>
+          <c:orientation val="maxMin"/>
         </c:scaling>
         <c:delete val="0"/>
         <c:axPos val="l"/>

</xml_diff>